<commit_message>
fix(sunum): kose suslerini temiz ucgen kamalarla degistir (kapak dahil, tasma yok)
- Kapak (slayt 1): tasan egik bantlar kaldirildi -> sol-ust + sag-alt iki tonlu
  ucgen kama (koseye tam oturur).
- Icerik slaytlari (2-9): havada duran donuk dikdortgen susler -> sag-ust + sag-alt
  ucgen kama. Tum sekiller slayt sinirinin icinde.
- PowerPoint COM ile slayt 1 & 3 render edilip gorsel dogrulandi.
- scripts/patch_sunum2.py (yerinde yama) + gen_sunum.py kaynagi ayni tasarima guncellendi.
  Slayt metinleri (ozellikle slayt 7) ellenmeden.
</commit_message>
<xml_diff>
--- a/docs/Finans_Portali_Sunum.pptx
+++ b/docs/Finans_Portali_Sunum.pptx
@@ -3146,16 +3146,187 @@
       </p:sp>
       <p:sp>
         <p:nvSpPr>
-          <p:cNvPr id="3" name="Rectangle 2"/>
+          <p:cNvPr id="6" name="TextBox 5"/>
+          <p:cNvSpPr txBox="1"/>
+          <p:nvPr/>
+        </p:nvSpPr>
+        <p:spPr>
+          <a:xfrm>
+            <a:off x="2194560" y="2011680"/>
+            <a:ext cx="8778240" cy="2560320"/>
+          </a:xfrm>
+          <a:prstGeom prst="rect">
+            <a:avLst/>
+          </a:prstGeom>
+          <a:noFill/>
+        </p:spPr>
+        <p:txBody>
+          <a:bodyPr wrap="square" lIns="0" tIns="0" rIns="0" bIns="0" anchor="t">
+            <a:spAutoFit/>
+          </a:bodyPr>
+          <a:lstStyle/>
+          <a:p>
+            <a:pPr algn="l">
+              <a:spcAft>
+                <a:spcPts val="600"/>
+              </a:spcAft>
+            </a:pPr>
+            <a:r>
+              <a:rPr sz="5800" b="1">
+                <a:solidFill>
+                  <a:srgbClr val="1E3A8A"/>
+                </a:solidFill>
+                <a:latin typeface="Cambria"/>
+              </a:rPr>
+              <a:t>Finans Portalı</a:t>
+            </a:r>
+          </a:p>
+          <a:p>
+            <a:pPr algn="l">
+              <a:spcAft>
+                <a:spcPts val="400"/>
+              </a:spcAft>
+            </a:pPr>
+            <a:r>
+              <a:rPr sz="2000" b="0">
+                <a:solidFill>
+                  <a:srgbClr val="475569"/>
+                </a:solidFill>
+                <a:latin typeface="Calibri"/>
+              </a:rPr>
+              <a:t>Çok-varlıklı finans portföy &amp; piyasa takip platformu</a:t>
+            </a:r>
+          </a:p>
+        </p:txBody>
+      </p:sp>
+      <p:sp>
+        <p:nvSpPr>
+          <p:cNvPr id="7" name="Rectangle 6"/>
           <p:cNvSpPr/>
           <p:nvPr/>
         </p:nvSpPr>
         <p:spPr>
-          <a:xfrm rot="720000">
-            <a:off x="-914400" y="-914400"/>
-            <a:ext cx="2743200" cy="8686800"/>
+          <a:xfrm>
+            <a:off x="2240280" y="3794760"/>
+            <a:ext cx="3291840" cy="54864"/>
           </a:xfrm>
           <a:prstGeom prst="rect">
+            <a:avLst/>
+          </a:prstGeom>
+          <a:solidFill>
+            <a:srgbClr val="1D4ED8"/>
+          </a:solidFill>
+          <a:ln>
+            <a:noFill/>
+          </a:ln>
+          <a:effectLst/>
+        </p:spPr>
+        <p:style>
+          <a:lnRef idx="1">
+            <a:schemeClr val="accent1"/>
+          </a:lnRef>
+          <a:fillRef idx="3">
+            <a:schemeClr val="accent1"/>
+          </a:fillRef>
+          <a:effectRef idx="2">
+            <a:schemeClr val="accent1"/>
+          </a:effectRef>
+          <a:fontRef idx="minor">
+            <a:schemeClr val="lt1"/>
+          </a:fontRef>
+        </p:style>
+        <p:txBody>
+          <a:bodyPr rtlCol="0" anchor="ctr"/>
+          <a:lstStyle/>
+          <a:p>
+            <a:pPr algn="ctr"/>
+            <a:endParaRPr/>
+          </a:p>
+        </p:txBody>
+      </p:sp>
+      <p:sp>
+        <p:nvSpPr>
+          <p:cNvPr id="8" name="TextBox 7"/>
+          <p:cNvSpPr txBox="1"/>
+          <p:nvPr/>
+        </p:nvSpPr>
+        <p:spPr>
+          <a:xfrm>
+            <a:off x="2194560" y="4069080"/>
+            <a:ext cx="8778240" cy="1645920"/>
+          </a:xfrm>
+          <a:prstGeom prst="rect">
+            <a:avLst/>
+          </a:prstGeom>
+          <a:noFill/>
+        </p:spPr>
+        <p:txBody>
+          <a:bodyPr wrap="square" lIns="0" tIns="0" rIns="0" bIns="0" anchor="t">
+            <a:spAutoFit/>
+          </a:bodyPr>
+          <a:lstStyle/>
+          <a:p>
+            <a:pPr algn="l">
+              <a:spcAft>
+                <a:spcPts val="1000"/>
+              </a:spcAft>
+            </a:pPr>
+            <a:r>
+              <a:rPr sz="2200" b="1">
+                <a:solidFill>
+                  <a:srgbClr val="1D4ED8"/>
+                </a:solidFill>
+                <a:latin typeface="Cambria"/>
+              </a:rPr>
+              <a:t>Proje Sunumu</a:t>
+            </a:r>
+          </a:p>
+          <a:p>
+            <a:pPr algn="l">
+              <a:spcAft>
+                <a:spcPts val="200"/>
+              </a:spcAft>
+            </a:pPr>
+            <a:r>
+              <a:rPr sz="1800" b="1">
+                <a:solidFill>
+                  <a:srgbClr val="1F2937"/>
+                </a:solidFill>
+                <a:latin typeface="Calibri"/>
+              </a:rPr>
+              <a:t>Yiğit Şeker</a:t>
+            </a:r>
+          </a:p>
+          <a:p>
+            <a:pPr algn="l">
+              <a:spcAft>
+                <a:spcPts val="600"/>
+              </a:spcAft>
+            </a:pPr>
+            <a:r>
+              <a:rPr sz="1400" b="0">
+                <a:solidFill>
+                  <a:srgbClr val="475569"/>
+                </a:solidFill>
+                <a:latin typeface="Calibri"/>
+              </a:rPr>
+              <a:t>Sakarya Üniversitesi · Yazılım Mühendisliği</a:t>
+            </a:r>
+          </a:p>
+        </p:txBody>
+      </p:sp>
+      <p:sp>
+        <p:nvSpPr>
+          <p:cNvPr id="9" name="Right Triangle 8"/>
+          <p:cNvSpPr/>
+          <p:nvPr/>
+        </p:nvSpPr>
+        <p:spPr>
+          <a:xfrm flipV="1">
+            <a:off x="0" y="0"/>
+            <a:ext cx="3017520" cy="2103120"/>
+          </a:xfrm>
+          <a:prstGeom prst="rtTriangle">
             <a:avLst/>
           </a:prstGeom>
           <a:solidFill>
@@ -3185,22 +3356,21 @@
           <a:lstStyle/>
           <a:p>
             <a:pPr algn="ctr"/>
-            <a:endParaRPr/>
-          </a:p>
-        </p:txBody>
-      </p:sp>
-      <p:sp>
-        <p:nvSpPr>
-          <p:cNvPr id="4" name="Rectangle 3"/>
+          </a:p>
+        </p:txBody>
+      </p:sp>
+      <p:sp>
+        <p:nvSpPr>
+          <p:cNvPr id="10" name="Right Triangle 9"/>
           <p:cNvSpPr/>
           <p:nvPr/>
         </p:nvSpPr>
         <p:spPr>
-          <a:xfrm rot="720000">
-            <a:off x="-1097280" y="-914400"/>
-            <a:ext cx="2011680" cy="8686800"/>
-          </a:xfrm>
-          <a:prstGeom prst="rect">
+          <a:xfrm flipV="1">
+            <a:off x="0" y="0"/>
+            <a:ext cx="1965960" cy="1371600"/>
+          </a:xfrm>
+          <a:prstGeom prst="rtTriangle">
             <a:avLst/>
           </a:prstGeom>
           <a:solidFill>
@@ -3230,22 +3400,21 @@
           <a:lstStyle/>
           <a:p>
             <a:pPr algn="ctr"/>
-            <a:endParaRPr/>
-          </a:p>
-        </p:txBody>
-      </p:sp>
-      <p:sp>
-        <p:nvSpPr>
-          <p:cNvPr id="5" name="Rectangle 4"/>
+          </a:p>
+        </p:txBody>
+      </p:sp>
+      <p:sp>
+        <p:nvSpPr>
+          <p:cNvPr id="11" name="Right Triangle 10"/>
           <p:cNvSpPr/>
           <p:nvPr/>
         </p:nvSpPr>
         <p:spPr>
-          <a:xfrm rot="1800000">
-            <a:off x="10698480" y="5394960"/>
-            <a:ext cx="2926080" cy="2377440"/>
-          </a:xfrm>
-          <a:prstGeom prst="rect">
+          <a:xfrm flipH="1">
+            <a:off x="9174480" y="4754880"/>
+            <a:ext cx="3017520" cy="2103120"/>
+          </a:xfrm>
+          <a:prstGeom prst="rtTriangle">
             <a:avLst/>
           </a:prstGeom>
           <a:solidFill>
@@ -3275,77 +3444,21 @@
           <a:lstStyle/>
           <a:p>
             <a:pPr algn="ctr"/>
-            <a:endParaRPr/>
-          </a:p>
-        </p:txBody>
-      </p:sp>
-      <p:sp>
-        <p:nvSpPr>
-          <p:cNvPr id="6" name="TextBox 5"/>
-          <p:cNvSpPr txBox="1"/>
-          <p:nvPr/>
-        </p:nvSpPr>
-        <p:spPr>
-          <a:xfrm>
-            <a:off x="2194560" y="2011680"/>
-            <a:ext cx="8778240" cy="2560320"/>
-          </a:xfrm>
-          <a:prstGeom prst="rect">
-            <a:avLst/>
-          </a:prstGeom>
-          <a:noFill/>
-        </p:spPr>
-        <p:txBody>
-          <a:bodyPr wrap="square" lIns="0" tIns="0" rIns="0" bIns="0" anchor="t">
-            <a:spAutoFit/>
-          </a:bodyPr>
-          <a:lstStyle/>
-          <a:p>
-            <a:pPr algn="l">
-              <a:spcAft>
-                <a:spcPts val="600"/>
-              </a:spcAft>
-            </a:pPr>
-            <a:r>
-              <a:rPr sz="5800" b="1">
-                <a:solidFill>
-                  <a:srgbClr val="1E3A8A"/>
-                </a:solidFill>
-                <a:latin typeface="Cambria"/>
-              </a:rPr>
-              <a:t>Finans Portalı</a:t>
-            </a:r>
-          </a:p>
-          <a:p>
-            <a:pPr algn="l">
-              <a:spcAft>
-                <a:spcPts val="400"/>
-              </a:spcAft>
-            </a:pPr>
-            <a:r>
-              <a:rPr sz="2000" b="0">
-                <a:solidFill>
-                  <a:srgbClr val="475569"/>
-                </a:solidFill>
-                <a:latin typeface="Calibri"/>
-              </a:rPr>
-              <a:t>Çok-varlıklı finans portföy &amp; piyasa takip platformu</a:t>
-            </a:r>
-          </a:p>
-        </p:txBody>
-      </p:sp>
-      <p:sp>
-        <p:nvSpPr>
-          <p:cNvPr id="7" name="Rectangle 6"/>
+          </a:p>
+        </p:txBody>
+      </p:sp>
+      <p:sp>
+        <p:nvSpPr>
+          <p:cNvPr id="12" name="Right Triangle 11"/>
           <p:cNvSpPr/>
           <p:nvPr/>
         </p:nvSpPr>
         <p:spPr>
-          <a:xfrm>
-            <a:off x="2240280" y="3794760"/>
-            <a:ext cx="3291840" cy="54864"/>
-          </a:xfrm>
-          <a:prstGeom prst="rect">
+          <a:xfrm flipH="1">
+            <a:off x="10226040" y="5486400"/>
+            <a:ext cx="1965960" cy="1371600"/>
+          </a:xfrm>
+          <a:prstGeom prst="rtTriangle">
             <a:avLst/>
           </a:prstGeom>
           <a:solidFill>
@@ -3375,78 +3488,6 @@
           <a:lstStyle/>
           <a:p>
             <a:pPr algn="ctr"/>
-            <a:endParaRPr/>
-          </a:p>
-        </p:txBody>
-      </p:sp>
-      <p:sp>
-        <p:nvSpPr>
-          <p:cNvPr id="8" name="TextBox 7"/>
-          <p:cNvSpPr txBox="1"/>
-          <p:nvPr/>
-        </p:nvSpPr>
-        <p:spPr>
-          <a:xfrm>
-            <a:off x="2194560" y="4069080"/>
-            <a:ext cx="8778240" cy="1645920"/>
-          </a:xfrm>
-          <a:prstGeom prst="rect">
-            <a:avLst/>
-          </a:prstGeom>
-          <a:noFill/>
-        </p:spPr>
-        <p:txBody>
-          <a:bodyPr wrap="square" lIns="0" tIns="0" rIns="0" bIns="0" anchor="t">
-            <a:spAutoFit/>
-          </a:bodyPr>
-          <a:lstStyle/>
-          <a:p>
-            <a:pPr algn="l">
-              <a:spcAft>
-                <a:spcPts val="1000"/>
-              </a:spcAft>
-            </a:pPr>
-            <a:r>
-              <a:rPr sz="2200" b="1">
-                <a:solidFill>
-                  <a:srgbClr val="1D4ED8"/>
-                </a:solidFill>
-                <a:latin typeface="Cambria"/>
-              </a:rPr>
-              <a:t>Proje Sunumu</a:t>
-            </a:r>
-          </a:p>
-          <a:p>
-            <a:pPr algn="l">
-              <a:spcAft>
-                <a:spcPts val="200"/>
-              </a:spcAft>
-            </a:pPr>
-            <a:r>
-              <a:rPr sz="1800" b="1">
-                <a:solidFill>
-                  <a:srgbClr val="1F2937"/>
-                </a:solidFill>
-                <a:latin typeface="Calibri"/>
-              </a:rPr>
-              <a:t>Yiğit Şeker</a:t>
-            </a:r>
-          </a:p>
-          <a:p>
-            <a:pPr algn="l">
-              <a:spcAft>
-                <a:spcPts val="600"/>
-              </a:spcAft>
-            </a:pPr>
-            <a:r>
-              <a:rPr sz="1400" b="0">
-                <a:solidFill>
-                  <a:srgbClr val="475569"/>
-                </a:solidFill>
-                <a:latin typeface="Calibri"/>
-              </a:rPr>
-              <a:t>Sakarya Üniversitesi · Yazılım Mühendisliği</a:t>
-            </a:r>
           </a:p>
         </p:txBody>
       </p:sp>
@@ -4075,16 +4116,16 @@
       </p:sp>
       <p:sp>
         <p:nvSpPr>
-          <p:cNvPr id="12" name="Rectangle 11"/>
+          <p:cNvPr id="12" name="Right Triangle 11"/>
           <p:cNvSpPr/>
           <p:nvPr/>
         </p:nvSpPr>
         <p:spPr>
-          <a:xfrm rot="2100000">
-            <a:off x="10835640" y="411480"/>
-            <a:ext cx="1280160" cy="457200"/>
-          </a:xfrm>
-          <a:prstGeom prst="rect">
+          <a:xfrm flipV="1" flipH="1">
+            <a:off x="10500360" y="0"/>
+            <a:ext cx="1691640" cy="1143000"/>
+          </a:xfrm>
+          <a:prstGeom prst="rtTriangle">
             <a:avLst/>
           </a:prstGeom>
           <a:solidFill>
@@ -4119,16 +4160,16 @@
       </p:sp>
       <p:sp>
         <p:nvSpPr>
-          <p:cNvPr id="13" name="Rectangle 12"/>
+          <p:cNvPr id="13" name="Right Triangle 12"/>
           <p:cNvSpPr/>
           <p:nvPr/>
         </p:nvSpPr>
         <p:spPr>
-          <a:xfrm rot="2100000">
-            <a:off x="11109960" y="274320"/>
-            <a:ext cx="1005840" cy="365760"/>
-          </a:xfrm>
-          <a:prstGeom prst="rect">
+          <a:xfrm flipV="1" flipH="1">
+            <a:off x="11094720" y="0"/>
+            <a:ext cx="1097280" cy="731520"/>
+          </a:xfrm>
+          <a:prstGeom prst="rtTriangle">
             <a:avLst/>
           </a:prstGeom>
           <a:solidFill>
@@ -4163,16 +4204,16 @@
       </p:sp>
       <p:sp>
         <p:nvSpPr>
-          <p:cNvPr id="14" name="Rectangle 13"/>
+          <p:cNvPr id="14" name="Right Triangle 13"/>
           <p:cNvSpPr/>
           <p:nvPr/>
         </p:nvSpPr>
         <p:spPr>
-          <a:xfrm rot="2100000">
-            <a:off x="10835640" y="5989320"/>
-            <a:ext cx="1280160" cy="457200"/>
-          </a:xfrm>
-          <a:prstGeom prst="rect">
+          <a:xfrm flipH="1">
+            <a:off x="10500360" y="5715000"/>
+            <a:ext cx="1691640" cy="1143000"/>
+          </a:xfrm>
+          <a:prstGeom prst="rtTriangle">
             <a:avLst/>
           </a:prstGeom>
           <a:solidFill>
@@ -4207,16 +4248,16 @@
       </p:sp>
       <p:sp>
         <p:nvSpPr>
-          <p:cNvPr id="15" name="Rectangle 14"/>
+          <p:cNvPr id="15" name="Right Triangle 14"/>
           <p:cNvSpPr/>
           <p:nvPr/>
         </p:nvSpPr>
         <p:spPr>
-          <a:xfrm rot="2100000">
-            <a:off x="11109960" y="6199632"/>
-            <a:ext cx="1005840" cy="365760"/>
-          </a:xfrm>
-          <a:prstGeom prst="rect">
+          <a:xfrm flipH="1">
+            <a:off x="11094720" y="6126480"/>
+            <a:ext cx="1097280" cy="731520"/>
+          </a:xfrm>
+          <a:prstGeom prst="rtTriangle">
             <a:avLst/>
           </a:prstGeom>
           <a:solidFill>
@@ -4563,16 +4604,16 @@
       </p:sp>
       <p:sp>
         <p:nvSpPr>
-          <p:cNvPr id="11" name="Rectangle 10"/>
+          <p:cNvPr id="11" name="Right Triangle 10"/>
           <p:cNvSpPr/>
           <p:nvPr/>
         </p:nvSpPr>
         <p:spPr>
-          <a:xfrm rot="2100000">
-            <a:off x="10835640" y="411480"/>
-            <a:ext cx="1280160" cy="457200"/>
-          </a:xfrm>
-          <a:prstGeom prst="rect">
+          <a:xfrm flipV="1" flipH="1">
+            <a:off x="10500360" y="0"/>
+            <a:ext cx="1691640" cy="1143000"/>
+          </a:xfrm>
+          <a:prstGeom prst="rtTriangle">
             <a:avLst/>
           </a:prstGeom>
           <a:solidFill>
@@ -4607,16 +4648,16 @@
       </p:sp>
       <p:sp>
         <p:nvSpPr>
-          <p:cNvPr id="12" name="Rectangle 11"/>
+          <p:cNvPr id="12" name="Right Triangle 11"/>
           <p:cNvSpPr/>
           <p:nvPr/>
         </p:nvSpPr>
         <p:spPr>
-          <a:xfrm rot="2100000">
-            <a:off x="11109960" y="274320"/>
-            <a:ext cx="1005840" cy="365760"/>
-          </a:xfrm>
-          <a:prstGeom prst="rect">
+          <a:xfrm flipV="1" flipH="1">
+            <a:off x="11094720" y="0"/>
+            <a:ext cx="1097280" cy="731520"/>
+          </a:xfrm>
+          <a:prstGeom prst="rtTriangle">
             <a:avLst/>
           </a:prstGeom>
           <a:solidFill>
@@ -4651,16 +4692,16 @@
       </p:sp>
       <p:sp>
         <p:nvSpPr>
-          <p:cNvPr id="13" name="Rectangle 12"/>
+          <p:cNvPr id="13" name="Right Triangle 12"/>
           <p:cNvSpPr/>
           <p:nvPr/>
         </p:nvSpPr>
         <p:spPr>
-          <a:xfrm rot="2100000">
-            <a:off x="10835640" y="5989320"/>
-            <a:ext cx="1280160" cy="457200"/>
-          </a:xfrm>
-          <a:prstGeom prst="rect">
+          <a:xfrm flipH="1">
+            <a:off x="10500360" y="5715000"/>
+            <a:ext cx="1691640" cy="1143000"/>
+          </a:xfrm>
+          <a:prstGeom prst="rtTriangle">
             <a:avLst/>
           </a:prstGeom>
           <a:solidFill>
@@ -4695,16 +4736,16 @@
       </p:sp>
       <p:sp>
         <p:nvSpPr>
-          <p:cNvPr id="14" name="Rectangle 13"/>
+          <p:cNvPr id="14" name="Right Triangle 13"/>
           <p:cNvSpPr/>
           <p:nvPr/>
         </p:nvSpPr>
         <p:spPr>
-          <a:xfrm rot="2100000">
-            <a:off x="11109960" y="6199632"/>
-            <a:ext cx="1005840" cy="365760"/>
-          </a:xfrm>
-          <a:prstGeom prst="rect">
+          <a:xfrm flipH="1">
+            <a:off x="11094720" y="6126480"/>
+            <a:ext cx="1097280" cy="731520"/>
+          </a:xfrm>
+          <a:prstGeom prst="rtTriangle">
             <a:avLst/>
           </a:prstGeom>
           <a:solidFill>
@@ -5763,16 +5804,16 @@
       </p:sp>
       <p:sp>
         <p:nvSpPr>
-          <p:cNvPr id="27" name="Rectangle 26"/>
+          <p:cNvPr id="27" name="Right Triangle 26"/>
           <p:cNvSpPr/>
           <p:nvPr/>
         </p:nvSpPr>
         <p:spPr>
-          <a:xfrm rot="2100000">
-            <a:off x="10835640" y="411480"/>
-            <a:ext cx="1280160" cy="457200"/>
-          </a:xfrm>
-          <a:prstGeom prst="rect">
+          <a:xfrm flipV="1" flipH="1">
+            <a:off x="10500360" y="0"/>
+            <a:ext cx="1691640" cy="1143000"/>
+          </a:xfrm>
+          <a:prstGeom prst="rtTriangle">
             <a:avLst/>
           </a:prstGeom>
           <a:solidFill>
@@ -5807,16 +5848,16 @@
       </p:sp>
       <p:sp>
         <p:nvSpPr>
-          <p:cNvPr id="28" name="Rectangle 27"/>
+          <p:cNvPr id="28" name="Right Triangle 27"/>
           <p:cNvSpPr/>
           <p:nvPr/>
         </p:nvSpPr>
         <p:spPr>
-          <a:xfrm rot="2100000">
-            <a:off x="11109960" y="274320"/>
-            <a:ext cx="1005840" cy="365760"/>
-          </a:xfrm>
-          <a:prstGeom prst="rect">
+          <a:xfrm flipV="1" flipH="1">
+            <a:off x="11094720" y="0"/>
+            <a:ext cx="1097280" cy="731520"/>
+          </a:xfrm>
+          <a:prstGeom prst="rtTriangle">
             <a:avLst/>
           </a:prstGeom>
           <a:solidFill>
@@ -5851,16 +5892,16 @@
       </p:sp>
       <p:sp>
         <p:nvSpPr>
-          <p:cNvPr id="29" name="Rectangle 28"/>
+          <p:cNvPr id="29" name="Right Triangle 28"/>
           <p:cNvSpPr/>
           <p:nvPr/>
         </p:nvSpPr>
         <p:spPr>
-          <a:xfrm rot="2100000">
-            <a:off x="10835640" y="5989320"/>
-            <a:ext cx="1280160" cy="457200"/>
-          </a:xfrm>
-          <a:prstGeom prst="rect">
+          <a:xfrm flipH="1">
+            <a:off x="10500360" y="5715000"/>
+            <a:ext cx="1691640" cy="1143000"/>
+          </a:xfrm>
+          <a:prstGeom prst="rtTriangle">
             <a:avLst/>
           </a:prstGeom>
           <a:solidFill>
@@ -5895,16 +5936,16 @@
       </p:sp>
       <p:sp>
         <p:nvSpPr>
-          <p:cNvPr id="30" name="Rectangle 29"/>
+          <p:cNvPr id="30" name="Right Triangle 29"/>
           <p:cNvSpPr/>
           <p:nvPr/>
         </p:nvSpPr>
         <p:spPr>
-          <a:xfrm rot="2100000">
-            <a:off x="11109960" y="6199632"/>
-            <a:ext cx="1005840" cy="365760"/>
-          </a:xfrm>
-          <a:prstGeom prst="rect">
+          <a:xfrm flipH="1">
+            <a:off x="11094720" y="6126480"/>
+            <a:ext cx="1097280" cy="731520"/>
+          </a:xfrm>
+          <a:prstGeom prst="rtTriangle">
             <a:avLst/>
           </a:prstGeom>
           <a:solidFill>
@@ -6753,16 +6794,16 @@
       </p:sp>
       <p:sp>
         <p:nvSpPr>
-          <p:cNvPr id="21" name="Rectangle 20"/>
+          <p:cNvPr id="21" name="Right Triangle 20"/>
           <p:cNvSpPr/>
           <p:nvPr/>
         </p:nvSpPr>
         <p:spPr>
-          <a:xfrm rot="2100000">
-            <a:off x="10835640" y="411480"/>
-            <a:ext cx="1280160" cy="457200"/>
-          </a:xfrm>
-          <a:prstGeom prst="rect">
+          <a:xfrm flipV="1" flipH="1">
+            <a:off x="10500360" y="0"/>
+            <a:ext cx="1691640" cy="1143000"/>
+          </a:xfrm>
+          <a:prstGeom prst="rtTriangle">
             <a:avLst/>
           </a:prstGeom>
           <a:solidFill>
@@ -6797,16 +6838,16 @@
       </p:sp>
       <p:sp>
         <p:nvSpPr>
-          <p:cNvPr id="22" name="Rectangle 21"/>
+          <p:cNvPr id="22" name="Right Triangle 21"/>
           <p:cNvSpPr/>
           <p:nvPr/>
         </p:nvSpPr>
         <p:spPr>
-          <a:xfrm rot="2100000">
-            <a:off x="11109960" y="274320"/>
-            <a:ext cx="1005840" cy="365760"/>
-          </a:xfrm>
-          <a:prstGeom prst="rect">
+          <a:xfrm flipV="1" flipH="1">
+            <a:off x="11094720" y="0"/>
+            <a:ext cx="1097280" cy="731520"/>
+          </a:xfrm>
+          <a:prstGeom prst="rtTriangle">
             <a:avLst/>
           </a:prstGeom>
           <a:solidFill>
@@ -6841,16 +6882,16 @@
       </p:sp>
       <p:sp>
         <p:nvSpPr>
-          <p:cNvPr id="23" name="Rectangle 22"/>
+          <p:cNvPr id="23" name="Right Triangle 22"/>
           <p:cNvSpPr/>
           <p:nvPr/>
         </p:nvSpPr>
         <p:spPr>
-          <a:xfrm rot="2100000">
-            <a:off x="10835640" y="5989320"/>
-            <a:ext cx="1280160" cy="457200"/>
-          </a:xfrm>
-          <a:prstGeom prst="rect">
+          <a:xfrm flipH="1">
+            <a:off x="10500360" y="5715000"/>
+            <a:ext cx="1691640" cy="1143000"/>
+          </a:xfrm>
+          <a:prstGeom prst="rtTriangle">
             <a:avLst/>
           </a:prstGeom>
           <a:solidFill>
@@ -6885,16 +6926,16 @@
       </p:sp>
       <p:sp>
         <p:nvSpPr>
-          <p:cNvPr id="24" name="Rectangle 23"/>
+          <p:cNvPr id="24" name="Right Triangle 23"/>
           <p:cNvSpPr/>
           <p:nvPr/>
         </p:nvSpPr>
         <p:spPr>
-          <a:xfrm rot="2100000">
-            <a:off x="11109960" y="6199632"/>
-            <a:ext cx="1005840" cy="365760"/>
-          </a:xfrm>
-          <a:prstGeom prst="rect">
+          <a:xfrm flipH="1">
+            <a:off x="11094720" y="6126480"/>
+            <a:ext cx="1097280" cy="731520"/>
+          </a:xfrm>
+          <a:prstGeom prst="rtTriangle">
             <a:avLst/>
           </a:prstGeom>
           <a:solidFill>
@@ -7449,16 +7490,16 @@
       </p:sp>
       <p:sp>
         <p:nvSpPr>
-          <p:cNvPr id="11" name="Rectangle 10"/>
+          <p:cNvPr id="11" name="Right Triangle 10"/>
           <p:cNvSpPr/>
           <p:nvPr/>
         </p:nvSpPr>
         <p:spPr>
-          <a:xfrm rot="2100000">
-            <a:off x="10835640" y="411480"/>
-            <a:ext cx="1280160" cy="457200"/>
-          </a:xfrm>
-          <a:prstGeom prst="rect">
+          <a:xfrm flipV="1" flipH="1">
+            <a:off x="10500360" y="0"/>
+            <a:ext cx="1691640" cy="1143000"/>
+          </a:xfrm>
+          <a:prstGeom prst="rtTriangle">
             <a:avLst/>
           </a:prstGeom>
           <a:solidFill>
@@ -7493,16 +7534,16 @@
       </p:sp>
       <p:sp>
         <p:nvSpPr>
-          <p:cNvPr id="12" name="Rectangle 11"/>
+          <p:cNvPr id="12" name="Right Triangle 11"/>
           <p:cNvSpPr/>
           <p:nvPr/>
         </p:nvSpPr>
         <p:spPr>
-          <a:xfrm rot="2100000">
-            <a:off x="11109960" y="274320"/>
-            <a:ext cx="1005840" cy="365760"/>
-          </a:xfrm>
-          <a:prstGeom prst="rect">
+          <a:xfrm flipV="1" flipH="1">
+            <a:off x="11094720" y="0"/>
+            <a:ext cx="1097280" cy="731520"/>
+          </a:xfrm>
+          <a:prstGeom prst="rtTriangle">
             <a:avLst/>
           </a:prstGeom>
           <a:solidFill>
@@ -7537,16 +7578,16 @@
       </p:sp>
       <p:sp>
         <p:nvSpPr>
-          <p:cNvPr id="13" name="Rectangle 12"/>
+          <p:cNvPr id="13" name="Right Triangle 12"/>
           <p:cNvSpPr/>
           <p:nvPr/>
         </p:nvSpPr>
         <p:spPr>
-          <a:xfrm rot="2100000">
-            <a:off x="10835640" y="5989320"/>
-            <a:ext cx="1280160" cy="457200"/>
-          </a:xfrm>
-          <a:prstGeom prst="rect">
+          <a:xfrm flipH="1">
+            <a:off x="10500360" y="5715000"/>
+            <a:ext cx="1691640" cy="1143000"/>
+          </a:xfrm>
+          <a:prstGeom prst="rtTriangle">
             <a:avLst/>
           </a:prstGeom>
           <a:solidFill>
@@ -7581,16 +7622,16 @@
       </p:sp>
       <p:sp>
         <p:nvSpPr>
-          <p:cNvPr id="14" name="Rectangle 13"/>
+          <p:cNvPr id="14" name="Right Triangle 13"/>
           <p:cNvSpPr/>
           <p:nvPr/>
         </p:nvSpPr>
         <p:spPr>
-          <a:xfrm rot="2100000">
-            <a:off x="11109960" y="6199632"/>
-            <a:ext cx="1005840" cy="365760"/>
-          </a:xfrm>
-          <a:prstGeom prst="rect">
+          <a:xfrm flipH="1">
+            <a:off x="11094720" y="6126480"/>
+            <a:ext cx="1097280" cy="731520"/>
+          </a:xfrm>
+          <a:prstGeom prst="rtTriangle">
             <a:avLst/>
           </a:prstGeom>
           <a:solidFill>
@@ -8461,16 +8502,16 @@
       </p:sp>
       <p:sp>
         <p:nvSpPr>
-          <p:cNvPr id="11" name="Rectangle 10"/>
+          <p:cNvPr id="11" name="Right Triangle 10"/>
           <p:cNvSpPr/>
           <p:nvPr/>
         </p:nvSpPr>
         <p:spPr>
-          <a:xfrm rot="2100000">
-            <a:off x="10835640" y="411480"/>
-            <a:ext cx="1280160" cy="457200"/>
-          </a:xfrm>
-          <a:prstGeom prst="rect">
+          <a:xfrm flipV="1" flipH="1">
+            <a:off x="10500360" y="0"/>
+            <a:ext cx="1691640" cy="1143000"/>
+          </a:xfrm>
+          <a:prstGeom prst="rtTriangle">
             <a:avLst/>
           </a:prstGeom>
           <a:solidFill>
@@ -8505,16 +8546,16 @@
       </p:sp>
       <p:sp>
         <p:nvSpPr>
-          <p:cNvPr id="12" name="Rectangle 11"/>
+          <p:cNvPr id="12" name="Right Triangle 11"/>
           <p:cNvSpPr/>
           <p:nvPr/>
         </p:nvSpPr>
         <p:spPr>
-          <a:xfrm rot="2100000">
-            <a:off x="11109960" y="274320"/>
-            <a:ext cx="1005840" cy="365760"/>
-          </a:xfrm>
-          <a:prstGeom prst="rect">
+          <a:xfrm flipV="1" flipH="1">
+            <a:off x="11094720" y="0"/>
+            <a:ext cx="1097280" cy="731520"/>
+          </a:xfrm>
+          <a:prstGeom prst="rtTriangle">
             <a:avLst/>
           </a:prstGeom>
           <a:solidFill>
@@ -8549,16 +8590,16 @@
       </p:sp>
       <p:sp>
         <p:nvSpPr>
-          <p:cNvPr id="13" name="Rectangle 12"/>
+          <p:cNvPr id="13" name="Right Triangle 12"/>
           <p:cNvSpPr/>
           <p:nvPr/>
         </p:nvSpPr>
         <p:spPr>
-          <a:xfrm rot="2100000">
-            <a:off x="10835640" y="5989320"/>
-            <a:ext cx="1280160" cy="457200"/>
-          </a:xfrm>
-          <a:prstGeom prst="rect">
+          <a:xfrm flipH="1">
+            <a:off x="10500360" y="5715000"/>
+            <a:ext cx="1691640" cy="1143000"/>
+          </a:xfrm>
+          <a:prstGeom prst="rtTriangle">
             <a:avLst/>
           </a:prstGeom>
           <a:solidFill>
@@ -8593,16 +8634,16 @@
       </p:sp>
       <p:sp>
         <p:nvSpPr>
-          <p:cNvPr id="14" name="Rectangle 13"/>
+          <p:cNvPr id="14" name="Right Triangle 13"/>
           <p:cNvSpPr/>
           <p:nvPr/>
         </p:nvSpPr>
         <p:spPr>
-          <a:xfrm rot="2100000">
-            <a:off x="11109960" y="6199632"/>
-            <a:ext cx="1005840" cy="365760"/>
-          </a:xfrm>
-          <a:prstGeom prst="rect">
+          <a:xfrm flipH="1">
+            <a:off x="11094720" y="6126480"/>
+            <a:ext cx="1097280" cy="731520"/>
+          </a:xfrm>
+          <a:prstGeom prst="rtTriangle">
             <a:avLst/>
           </a:prstGeom>
           <a:solidFill>
@@ -9004,16 +9045,16 @@
       </p:sp>
       <p:sp>
         <p:nvSpPr>
-          <p:cNvPr id="12" name="Rectangle 11"/>
+          <p:cNvPr id="12" name="Right Triangle 11"/>
           <p:cNvSpPr/>
           <p:nvPr/>
         </p:nvSpPr>
         <p:spPr>
-          <a:xfrm rot="2100000">
-            <a:off x="10835640" y="411480"/>
-            <a:ext cx="1280160" cy="457200"/>
-          </a:xfrm>
-          <a:prstGeom prst="rect">
+          <a:xfrm flipV="1" flipH="1">
+            <a:off x="10500360" y="0"/>
+            <a:ext cx="1691640" cy="1143000"/>
+          </a:xfrm>
+          <a:prstGeom prst="rtTriangle">
             <a:avLst/>
           </a:prstGeom>
           <a:solidFill>
@@ -9048,16 +9089,16 @@
       </p:sp>
       <p:sp>
         <p:nvSpPr>
-          <p:cNvPr id="13" name="Rectangle 12"/>
+          <p:cNvPr id="13" name="Right Triangle 12"/>
           <p:cNvSpPr/>
           <p:nvPr/>
         </p:nvSpPr>
         <p:spPr>
-          <a:xfrm rot="2100000">
-            <a:off x="11109960" y="274320"/>
-            <a:ext cx="1005840" cy="365760"/>
-          </a:xfrm>
-          <a:prstGeom prst="rect">
+          <a:xfrm flipV="1" flipH="1">
+            <a:off x="11094720" y="0"/>
+            <a:ext cx="1097280" cy="731520"/>
+          </a:xfrm>
+          <a:prstGeom prst="rtTriangle">
             <a:avLst/>
           </a:prstGeom>
           <a:solidFill>
@@ -9092,16 +9133,16 @@
       </p:sp>
       <p:sp>
         <p:nvSpPr>
-          <p:cNvPr id="14" name="Rectangle 13"/>
+          <p:cNvPr id="14" name="Right Triangle 13"/>
           <p:cNvSpPr/>
           <p:nvPr/>
         </p:nvSpPr>
         <p:spPr>
-          <a:xfrm rot="2100000">
-            <a:off x="10835640" y="5989320"/>
-            <a:ext cx="1280160" cy="457200"/>
-          </a:xfrm>
-          <a:prstGeom prst="rect">
+          <a:xfrm flipH="1">
+            <a:off x="10500360" y="5715000"/>
+            <a:ext cx="1691640" cy="1143000"/>
+          </a:xfrm>
+          <a:prstGeom prst="rtTriangle">
             <a:avLst/>
           </a:prstGeom>
           <a:solidFill>
@@ -9136,16 +9177,16 @@
       </p:sp>
       <p:sp>
         <p:nvSpPr>
-          <p:cNvPr id="15" name="Rectangle 14"/>
+          <p:cNvPr id="15" name="Right Triangle 14"/>
           <p:cNvSpPr/>
           <p:nvPr/>
         </p:nvSpPr>
         <p:spPr>
-          <a:xfrm rot="2100000">
-            <a:off x="11109960" y="6199632"/>
-            <a:ext cx="1005840" cy="365760"/>
-          </a:xfrm>
-          <a:prstGeom prst="rect">
+          <a:xfrm flipH="1">
+            <a:off x="11094720" y="6126480"/>
+            <a:ext cx="1097280" cy="731520"/>
+          </a:xfrm>
+          <a:prstGeom prst="rtTriangle">
             <a:avLst/>
           </a:prstGeom>
           <a:solidFill>
@@ -9507,16 +9548,16 @@
       </p:sp>
       <p:sp>
         <p:nvSpPr>
-          <p:cNvPr id="12" name="Rectangle 11"/>
+          <p:cNvPr id="12" name="Right Triangle 11"/>
           <p:cNvSpPr/>
           <p:nvPr/>
         </p:nvSpPr>
         <p:spPr>
-          <a:xfrm rot="2100000">
-            <a:off x="10835640" y="411480"/>
-            <a:ext cx="1280160" cy="457200"/>
-          </a:xfrm>
-          <a:prstGeom prst="rect">
+          <a:xfrm flipV="1" flipH="1">
+            <a:off x="10500360" y="0"/>
+            <a:ext cx="1691640" cy="1143000"/>
+          </a:xfrm>
+          <a:prstGeom prst="rtTriangle">
             <a:avLst/>
           </a:prstGeom>
           <a:solidFill>
@@ -9551,16 +9592,16 @@
       </p:sp>
       <p:sp>
         <p:nvSpPr>
-          <p:cNvPr id="13" name="Rectangle 12"/>
+          <p:cNvPr id="13" name="Right Triangle 12"/>
           <p:cNvSpPr/>
           <p:nvPr/>
         </p:nvSpPr>
         <p:spPr>
-          <a:xfrm rot="2100000">
-            <a:off x="11109960" y="274320"/>
-            <a:ext cx="1005840" cy="365760"/>
-          </a:xfrm>
-          <a:prstGeom prst="rect">
+          <a:xfrm flipV="1" flipH="1">
+            <a:off x="11094720" y="0"/>
+            <a:ext cx="1097280" cy="731520"/>
+          </a:xfrm>
+          <a:prstGeom prst="rtTriangle">
             <a:avLst/>
           </a:prstGeom>
           <a:solidFill>
@@ -9595,16 +9636,16 @@
       </p:sp>
       <p:sp>
         <p:nvSpPr>
-          <p:cNvPr id="14" name="Rectangle 13"/>
+          <p:cNvPr id="14" name="Right Triangle 13"/>
           <p:cNvSpPr/>
           <p:nvPr/>
         </p:nvSpPr>
         <p:spPr>
-          <a:xfrm rot="2100000">
-            <a:off x="10835640" y="5989320"/>
-            <a:ext cx="1280160" cy="457200"/>
-          </a:xfrm>
-          <a:prstGeom prst="rect">
+          <a:xfrm flipH="1">
+            <a:off x="10500360" y="5715000"/>
+            <a:ext cx="1691640" cy="1143000"/>
+          </a:xfrm>
+          <a:prstGeom prst="rtTriangle">
             <a:avLst/>
           </a:prstGeom>
           <a:solidFill>
@@ -9639,16 +9680,16 @@
       </p:sp>
       <p:sp>
         <p:nvSpPr>
-          <p:cNvPr id="15" name="Rectangle 14"/>
+          <p:cNvPr id="15" name="Right Triangle 14"/>
           <p:cNvSpPr/>
           <p:nvPr/>
         </p:nvSpPr>
         <p:spPr>
-          <a:xfrm rot="2100000">
-            <a:off x="11109960" y="6199632"/>
-            <a:ext cx="1005840" cy="365760"/>
-          </a:xfrm>
-          <a:prstGeom prst="rect">
+          <a:xfrm flipH="1">
+            <a:off x="11094720" y="6126480"/>
+            <a:ext cx="1097280" cy="731520"/>
+          </a:xfrm>
+          <a:prstGeom prst="rtTriangle">
             <a:avLst/>
           </a:prstGeom>
           <a:solidFill>

</xml_diff>

<commit_message>
fix(sunum): kapanis slaytindaki tasan mavi bandi kose kamalariyla degistir
Slayt 10 (Tesekkurler): tasan egik mavi bant kaldirildi -> lacivert zemin uzerine
sol-ust + sag-alt iki tonlu mavi ucgen kama (koseye oturur, tasma yok). PowerPoint
COM ile render edilip dogrulandi. gen_sunum.py kapanisi da ayni tasarima guncellendi.
</commit_message>
<xml_diff>
--- a/docs/Finans_Portali_Sunum.pptx
+++ b/docs/Finans_Portali_Sunum.pptx
@@ -3563,16 +3563,103 @@
       </p:sp>
       <p:sp>
         <p:nvSpPr>
-          <p:cNvPr id="3" name="Rectangle 2"/>
+          <p:cNvPr id="4" name="TextBox 3"/>
+          <p:cNvSpPr txBox="1"/>
+          <p:nvPr/>
+        </p:nvSpPr>
+        <p:spPr>
+          <a:xfrm>
+            <a:off x="2194560" y="2377440"/>
+            <a:ext cx="8778240" cy="2377440"/>
+          </a:xfrm>
+          <a:prstGeom prst="rect">
+            <a:avLst/>
+          </a:prstGeom>
+          <a:noFill/>
+        </p:spPr>
+        <p:txBody>
+          <a:bodyPr wrap="square" lIns="0" tIns="0" rIns="0" bIns="0" anchor="t">
+            <a:spAutoFit/>
+          </a:bodyPr>
+          <a:lstStyle/>
+          <a:p>
+            <a:pPr algn="l">
+              <a:spcAft>
+                <a:spcPts val="1000"/>
+              </a:spcAft>
+            </a:pPr>
+            <a:r>
+              <a:rPr sz="4600" b="1">
+                <a:solidFill>
+                  <a:srgbClr val="FFFFFF"/>
+                </a:solidFill>
+                <a:latin typeface="Cambria"/>
+              </a:rPr>
+              <a:t>Teşekkürler</a:t>
+            </a:r>
+          </a:p>
+          <a:p>
+            <a:pPr algn="l">
+              <a:spcAft>
+                <a:spcPts val="600"/>
+              </a:spcAft>
+            </a:pPr>
+            <a:r>
+              <a:rPr sz="1700" b="0">
+                <a:solidFill>
+                  <a:srgbClr val="DBEAFE"/>
+                </a:solidFill>
+                <a:latin typeface="Calibri"/>
+              </a:rPr>
+              <a:t>Finans Portalı — çok-varlıklı finans portföy &amp; piyasa takip platformu</a:t>
+            </a:r>
+          </a:p>
+          <a:p>
+            <a:pPr algn="l">
+              <a:spcAft>
+                <a:spcPts val="200"/>
+              </a:spcAft>
+            </a:pPr>
+            <a:r>
+              <a:rPr sz="1500" b="0">
+                <a:solidFill>
+                  <a:srgbClr val="FFFFFF"/>
+                </a:solidFill>
+                <a:latin typeface="Calibri"/>
+              </a:rPr>
+              <a:t>Yiğit Şeker · Sakarya Üniversitesi Yazılım Mühendisliği</a:t>
+            </a:r>
+          </a:p>
+          <a:p>
+            <a:pPr algn="l">
+              <a:spcAft>
+                <a:spcPts val="600"/>
+              </a:spcAft>
+            </a:pPr>
+            <a:r>
+              <a:rPr sz="1400" b="0">
+                <a:solidFill>
+                  <a:srgbClr val="DBEAFE"/>
+                </a:solidFill>
+                <a:latin typeface="Calibri"/>
+              </a:rPr>
+              <a:t>GitHub: github.com/yigitsheker/finans-portali</a:t>
+            </a:r>
+          </a:p>
+        </p:txBody>
+      </p:sp>
+      <p:sp>
+        <p:nvSpPr>
+          <p:cNvPr id="5" name="Right Triangle 4"/>
           <p:cNvSpPr/>
           <p:nvPr/>
         </p:nvSpPr>
         <p:spPr>
-          <a:xfrm rot="720000">
-            <a:off x="-914400" y="-914400"/>
-            <a:ext cx="2743200" cy="8686800"/>
-          </a:xfrm>
-          <a:prstGeom prst="rect">
+          <a:xfrm flipV="1">
+            <a:off x="0" y="0"/>
+            <a:ext cx="3017520" cy="2103120"/>
+          </a:xfrm>
+          <a:prstGeom prst="rtTriangle">
             <a:avLst/>
           </a:prstGeom>
           <a:solidFill>
@@ -3602,94 +3689,138 @@
           <a:lstStyle/>
           <a:p>
             <a:pPr algn="ctr"/>
-            <a:endParaRPr/>
-          </a:p>
-        </p:txBody>
-      </p:sp>
-      <p:sp>
-        <p:nvSpPr>
-          <p:cNvPr id="4" name="TextBox 3"/>
-          <p:cNvSpPr txBox="1"/>
-          <p:nvPr/>
-        </p:nvSpPr>
-        <p:spPr>
-          <a:xfrm>
-            <a:off x="2194560" y="2377440"/>
-            <a:ext cx="8778240" cy="2377440"/>
-          </a:xfrm>
-          <a:prstGeom prst="rect">
-            <a:avLst/>
-          </a:prstGeom>
-          <a:noFill/>
-        </p:spPr>
-        <p:txBody>
-          <a:bodyPr wrap="square" lIns="0" tIns="0" rIns="0" bIns="0" anchor="t">
-            <a:spAutoFit/>
-          </a:bodyPr>
-          <a:lstStyle/>
-          <a:p>
-            <a:pPr algn="l">
-              <a:spcAft>
-                <a:spcPts val="1000"/>
-              </a:spcAft>
-            </a:pPr>
-            <a:r>
-              <a:rPr sz="4600" b="1">
-                <a:solidFill>
-                  <a:srgbClr val="FFFFFF"/>
-                </a:solidFill>
-                <a:latin typeface="Cambria"/>
-              </a:rPr>
-              <a:t>Teşekkürler</a:t>
-            </a:r>
-          </a:p>
-          <a:p>
-            <a:pPr algn="l">
-              <a:spcAft>
-                <a:spcPts val="600"/>
-              </a:spcAft>
-            </a:pPr>
-            <a:r>
-              <a:rPr sz="1700" b="0">
-                <a:solidFill>
-                  <a:srgbClr val="DBEAFE"/>
-                </a:solidFill>
-                <a:latin typeface="Calibri"/>
-              </a:rPr>
-              <a:t>Finans Portalı — çok-varlıklı finans portföy &amp; piyasa takip platformu</a:t>
-            </a:r>
-          </a:p>
-          <a:p>
-            <a:pPr algn="l">
-              <a:spcAft>
-                <a:spcPts val="200"/>
-              </a:spcAft>
-            </a:pPr>
-            <a:r>
-              <a:rPr sz="1500" b="0">
-                <a:solidFill>
-                  <a:srgbClr val="FFFFFF"/>
-                </a:solidFill>
-                <a:latin typeface="Calibri"/>
-              </a:rPr>
-              <a:t>Yiğit Şeker · Sakarya Üniversitesi Yazılım Mühendisliği</a:t>
-            </a:r>
-          </a:p>
-          <a:p>
-            <a:pPr algn="l">
-              <a:spcAft>
-                <a:spcPts val="600"/>
-              </a:spcAft>
-            </a:pPr>
-            <a:r>
-              <a:rPr sz="1400" b="0">
-                <a:solidFill>
-                  <a:srgbClr val="DBEAFE"/>
-                </a:solidFill>
-                <a:latin typeface="Calibri"/>
-              </a:rPr>
-              <a:t>GitHub: github.com/yigitsheker/finans-portali</a:t>
-            </a:r>
+          </a:p>
+        </p:txBody>
+      </p:sp>
+      <p:sp>
+        <p:nvSpPr>
+          <p:cNvPr id="6" name="Right Triangle 5"/>
+          <p:cNvSpPr/>
+          <p:nvPr/>
+        </p:nvSpPr>
+        <p:spPr>
+          <a:xfrm flipV="1">
+            <a:off x="0" y="0"/>
+            <a:ext cx="1965960" cy="1371600"/>
+          </a:xfrm>
+          <a:prstGeom prst="rtTriangle">
+            <a:avLst/>
+          </a:prstGeom>
+          <a:solidFill>
+            <a:srgbClr val="60A5FA"/>
+          </a:solidFill>
+          <a:ln>
+            <a:noFill/>
+          </a:ln>
+          <a:effectLst/>
+        </p:spPr>
+        <p:style>
+          <a:lnRef idx="1">
+            <a:schemeClr val="accent1"/>
+          </a:lnRef>
+          <a:fillRef idx="3">
+            <a:schemeClr val="accent1"/>
+          </a:fillRef>
+          <a:effectRef idx="2">
+            <a:schemeClr val="accent1"/>
+          </a:effectRef>
+          <a:fontRef idx="minor">
+            <a:schemeClr val="lt1"/>
+          </a:fontRef>
+        </p:style>
+        <p:txBody>
+          <a:bodyPr rtlCol="0" anchor="ctr"/>
+          <a:lstStyle/>
+          <a:p>
+            <a:pPr algn="ctr"/>
+          </a:p>
+        </p:txBody>
+      </p:sp>
+      <p:sp>
+        <p:nvSpPr>
+          <p:cNvPr id="7" name="Right Triangle 6"/>
+          <p:cNvSpPr/>
+          <p:nvPr/>
+        </p:nvSpPr>
+        <p:spPr>
+          <a:xfrm flipH="1">
+            <a:off x="9174480" y="4754880"/>
+            <a:ext cx="3017520" cy="2103120"/>
+          </a:xfrm>
+          <a:prstGeom prst="rtTriangle">
+            <a:avLst/>
+          </a:prstGeom>
+          <a:solidFill>
+            <a:srgbClr val="1D4ED8"/>
+          </a:solidFill>
+          <a:ln>
+            <a:noFill/>
+          </a:ln>
+          <a:effectLst/>
+        </p:spPr>
+        <p:style>
+          <a:lnRef idx="1">
+            <a:schemeClr val="accent1"/>
+          </a:lnRef>
+          <a:fillRef idx="3">
+            <a:schemeClr val="accent1"/>
+          </a:fillRef>
+          <a:effectRef idx="2">
+            <a:schemeClr val="accent1"/>
+          </a:effectRef>
+          <a:fontRef idx="minor">
+            <a:schemeClr val="lt1"/>
+          </a:fontRef>
+        </p:style>
+        <p:txBody>
+          <a:bodyPr rtlCol="0" anchor="ctr"/>
+          <a:lstStyle/>
+          <a:p>
+            <a:pPr algn="ctr"/>
+          </a:p>
+        </p:txBody>
+      </p:sp>
+      <p:sp>
+        <p:nvSpPr>
+          <p:cNvPr id="8" name="Right Triangle 7"/>
+          <p:cNvSpPr/>
+          <p:nvPr/>
+        </p:nvSpPr>
+        <p:spPr>
+          <a:xfrm flipH="1">
+            <a:off x="10226040" y="5486400"/>
+            <a:ext cx="1965960" cy="1371600"/>
+          </a:xfrm>
+          <a:prstGeom prst="rtTriangle">
+            <a:avLst/>
+          </a:prstGeom>
+          <a:solidFill>
+            <a:srgbClr val="60A5FA"/>
+          </a:solidFill>
+          <a:ln>
+            <a:noFill/>
+          </a:ln>
+          <a:effectLst/>
+        </p:spPr>
+        <p:style>
+          <a:lnRef idx="1">
+            <a:schemeClr val="accent1"/>
+          </a:lnRef>
+          <a:fillRef idx="3">
+            <a:schemeClr val="accent1"/>
+          </a:fillRef>
+          <a:effectRef idx="2">
+            <a:schemeClr val="accent1"/>
+          </a:effectRef>
+          <a:fontRef idx="minor">
+            <a:schemeClr val="lt1"/>
+          </a:fontRef>
+        </p:style>
+        <p:txBody>
+          <a:bodyPr rtlCol="0" anchor="ctr"/>
+          <a:lstStyle/>
+          <a:p>
+            <a:pPr algn="ctr"/>
           </a:p>
         </p:txBody>
       </p:sp>

</xml_diff>